<commit_message>
STMS: conventional vs ours demo, ambulance, team split
</commit_message>
<xml_diff>
--- a/deliverables/STMS_Presentation.pptx
+++ b/deliverables/STMS_Presentation.pptx
@@ -1396,7 +1396,7 @@
                 </a:solidFill>
                 <a:latin typeface="Arial"/>
               </a:rPr>
-              <a:t>Ambulance (s)</a:t>
+              <a:t>S3 ambulance (s)</a:t>
             </a:r>
           </a:p>
         </c:rich>
@@ -3504,7 +3504,7 @@
           <a:p>
             <a:r>
               <a:rPr lang="en-US" dirty="0"/>
-              <a:t>Presenter: M4. This conflict was not scripted: the bus happened to propose while the ambulance held INT_10, and the intersection rejected it with a reason.</a:t>
+              <a:t>Presenter: M4. These are the real messages of the demo run: python run_simulation.py --protocol prints the same log.</a:t>
             </a:r>
             <a:endParaRPr lang="en-US" dirty="0"/>
           </a:p>
@@ -3592,7 +3592,7 @@
           <a:p>
             <a:r>
               <a:rPr lang="en-US" dirty="0"/>
-              <a:t>Presenter: M4. Stress that both runs in S3 use the same Max-Pressure controller. The old version compared against fixed-time, which mixed two effects.</a:t>
+              <a:t>Presenter: M4. S3 uses the same Max-Pressure controller in both runs. S5 compares a conventional city (fixed-time lights, no alerts, no preemption) with ours on identical traffic and the identical accident.</a:t>
             </a:r>
             <a:endParaRPr lang="en-US" dirty="0"/>
           </a:p>
@@ -4560,7 +4560,7 @@
           <a:p>
             <a:r>
               <a:rPr lang="en-US" dirty="0"/>
-              <a:t>Each member presents their own agent's row: M2 intersection, M3 vehicle, M4 ambulance and bus, M5 coordinator.</a:t>
+              <a:t>Each member presents their own agent's row: M2 intersection, M3 vehicle, M4 ambulance, M5 coordinator.</a:t>
             </a:r>
             <a:endParaRPr lang="en-US" dirty="0"/>
           </a:p>
@@ -5432,7 +5432,7 @@
                 <a:ea typeface="Calibri" pitchFamily="34" charset="-122"/>
                 <a:cs typeface="Calibri" pitchFamily="34" charset="-120"/>
               </a:rPr>
-              <a:t>A multi-agent AI system: Max-Pressure signals, A* routing, ambulance preemption, negotiated bus priority, hill-climbing tuning</a:t>
+              <a:t>A multi-agent AI system: Max-Pressure signals, A* routing, ambulance preemption, accident re-routing, hill-climbing tuning</a:t>
             </a:r>
             <a:endParaRPr lang="en-US" sz="1500" dirty="0"/>
           </a:p>
@@ -8685,7 +8685,7 @@
                 <a:ea typeface="Calibri" pitchFamily="34" charset="-122"/>
                 <a:cs typeface="Calibri" pitchFamily="34" charset="-120"/>
               </a:rPr>
-              <a:t>Ambulance: PREEMPT_OVERRIDE -&gt; AGREE -&gt; CANCEL. Absolute, but always via yellow.</a:t>
+              <a:t>Accident: one BROADCAST from the traffic centre; each car checks its route and re-runs A*.</a:t>
             </a:r>
             <a:endParaRPr lang="en-US" sz="1100" dirty="0"/>
           </a:p>
@@ -8705,7 +8705,7 @@
                 <a:ea typeface="Calibri" pitchFamily="34" charset="-122"/>
                 <a:cs typeface="Calibri" pitchFamily="34" charset="-120"/>
               </a:rPr>
-              <a:t>Bus: PROPOSE -&gt; ACCEPT or REJECT. The junction decides; refused here because the ambulance holds INT_10.</a:t>
+              <a:t>Ambulance: PREEMPT_OVERRIDE -&gt; AGREE -&gt; CANCEL. Absolute, but always via yellow.</a:t>
             </a:r>
             <a:endParaRPr lang="en-US" sz="1100" dirty="0"/>
           </a:p>
@@ -8776,7 +8776,7 @@
                 <a:ea typeface="Arial" pitchFamily="34" charset="-122"/>
                 <a:cs typeface="Arial" pitchFamily="34" charset="-120"/>
               </a:rPr>
-              <a:t>Results: priority vehicles</a:t>
+              <a:t>Results: ambulance and conventional vs ours</a:t>
             </a:r>
             <a:endParaRPr lang="en-US" sz="2400" dirty="0"/>
           </a:p>
@@ -8815,7 +8815,7 @@
                 <a:ea typeface="Calibri" pitchFamily="34" charset="-122"/>
                 <a:cs typeface="Calibri" pitchFamily="34" charset="-120"/>
               </a:rPr>
-              <a:t>S3 same controller, preemption off vs on  |  S5 bus priority, 4 buses x 40 passengers</a:t>
+              <a:t>S3 same controller, preemption off vs on  |  S5 whole city: conventional vs our system</a:t>
             </a:r>
             <a:endParaRPr lang="en-US" sz="1300" dirty="0"/>
           </a:p>
@@ -8965,9 +8965,9 @@
             <a:tbl>
               <a:tblPr/>
               <a:tblGrid>
-                <a:gridCol w="1554480"/>
-                <a:gridCol w="1234440"/>
-                <a:gridCol w="1234440"/>
+                <a:gridCol w="1828800"/>
+                <a:gridCol w="1097280"/>
+                <a:gridCol w="1097280"/>
               </a:tblGrid>
               <a:tr h="365760">
                 <a:tc>
@@ -8987,7 +8987,7 @@
                           <a:ea typeface="Calibri" pitchFamily="34" charset="-122"/>
                           <a:cs typeface="Calibri" pitchFamily="34" charset="-120"/>
                         </a:rPr>
-                        <a:t>Bus priority</a:t>
+                        <a:t>S5 (accident + ambulance)</a:t>
                       </a:r>
                       <a:endParaRPr lang="en-US" sz="1150" dirty="0">
                         <a:latin typeface="Calibri" charset="0"/>
@@ -9055,7 +9055,7 @@
                           <a:ea typeface="Calibri" pitchFamily="34" charset="-122"/>
                           <a:cs typeface="Calibri" pitchFamily="34" charset="-120"/>
                         </a:rPr>
-                        <a:t>Light cross</a:t>
+                        <a:t>Conventional</a:t>
                       </a:r>
                       <a:endParaRPr lang="en-US" sz="1150" dirty="0">
                         <a:latin typeface="Calibri" charset="0"/>
@@ -9123,7 +9123,7 @@
                           <a:ea typeface="Calibri" pitchFamily="34" charset="-122"/>
                           <a:cs typeface="Calibri" pitchFamily="34" charset="-120"/>
                         </a:rPr>
-                        <a:t>Heavy cross</a:t>
+                        <a:t>Ours</a:t>
                       </a:r>
                       <a:endParaRPr lang="en-US" sz="1150" dirty="0">
                         <a:latin typeface="Calibri" charset="0"/>
@@ -9193,7 +9193,7 @@
                           <a:ea typeface="Calibri" pitchFamily="34" charset="-122"/>
                           <a:cs typeface="Calibri" pitchFamily="34" charset="-120"/>
                         </a:rPr>
-                        <a:t>Bus travel (s)</a:t>
+                        <a:t>Ambulance trip (s)</a:t>
                       </a:r>
                       <a:endParaRPr lang="en-US" sz="1150" dirty="0">
                         <a:latin typeface="Calibri" charset="0"/>
@@ -9261,7 +9261,7 @@
                           <a:ea typeface="Calibri" pitchFamily="34" charset="-122"/>
                           <a:cs typeface="Calibri" pitchFamily="34" charset="-120"/>
                         </a:rPr>
-                        <a:t>63.8 -&gt; 58.0</a:t>
+                        <a:t>126.0</a:t>
                       </a:r>
                       <a:endParaRPr lang="en-US" sz="1150" dirty="0">
                         <a:latin typeface="Calibri" charset="0"/>
@@ -9329,7 +9329,7 @@
                           <a:ea typeface="Calibri" pitchFamily="34" charset="-122"/>
                           <a:cs typeface="Calibri" pitchFamily="34" charset="-120"/>
                         </a:rPr>
-                        <a:t>63.3 -&gt; 59.5</a:t>
+                        <a:t>73.0</a:t>
                       </a:r>
                       <a:endParaRPr lang="en-US" sz="1150" dirty="0">
                         <a:latin typeface="Calibri" charset="0"/>
@@ -9399,7 +9399,7 @@
                           <a:ea typeface="Calibri" pitchFamily="34" charset="-122"/>
                           <a:cs typeface="Calibri" pitchFamily="34" charset="-120"/>
                         </a:rPr>
-                        <a:t>Car wait (s)</a:t>
+                        <a:t>Ambulance wait at red (s)</a:t>
                       </a:r>
                       <a:endParaRPr lang="en-US" sz="1150" dirty="0">
                         <a:latin typeface="Calibri" charset="0"/>
@@ -9467,7 +9467,7 @@
                           <a:ea typeface="Calibri" pitchFamily="34" charset="-122"/>
                           <a:cs typeface="Calibri" pitchFamily="34" charset="-120"/>
                         </a:rPr>
-                        <a:t>2.41 -&gt; 4.76</a:t>
+                        <a:t>47.0</a:t>
                       </a:r>
                       <a:endParaRPr lang="en-US" sz="1150" dirty="0">
                         <a:latin typeface="Calibri" charset="0"/>
@@ -9535,7 +9535,7 @@
                           <a:ea typeface="Calibri" pitchFamily="34" charset="-122"/>
                           <a:cs typeface="Calibri" pitchFamily="34" charset="-120"/>
                         </a:rPr>
-                        <a:t>2.87 -&gt; 4.12</a:t>
+                        <a:t>0.0</a:t>
                       </a:r>
                       <a:endParaRPr lang="en-US" sz="1150" dirty="0">
                         <a:latin typeface="Calibri" charset="0"/>
@@ -9605,7 +9605,7 @@
                           <a:ea typeface="Calibri" pitchFamily="34" charset="-122"/>
                           <a:cs typeface="Calibri" pitchFamily="34" charset="-120"/>
                         </a:rPr>
-                        <a:t>Accepted / rejected</a:t>
+                        <a:t>Avg wait per car (s)</a:t>
                       </a:r>
                       <a:endParaRPr lang="en-US" sz="1150" dirty="0">
                         <a:latin typeface="Calibri" charset="0"/>
@@ -9673,7 +9673,7 @@
                           <a:ea typeface="Calibri" pitchFamily="34" charset="-122"/>
                           <a:cs typeface="Calibri" pitchFamily="34" charset="-120"/>
                         </a:rPr>
-                        <a:t>64 / 0</a:t>
+                        <a:t>21.25</a:t>
                       </a:r>
                       <a:endParaRPr lang="en-US" sz="1150" dirty="0">
                         <a:latin typeface="Calibri" charset="0"/>
@@ -9741,7 +9741,7 @@
                           <a:ea typeface="Calibri" pitchFamily="34" charset="-122"/>
                           <a:cs typeface="Calibri" pitchFamily="34" charset="-120"/>
                         </a:rPr>
-                        <a:t>43 / 21</a:t>
+                        <a:t>9.28</a:t>
                       </a:r>
                       <a:endParaRPr lang="en-US" sz="1150" dirty="0">
                         <a:latin typeface="Calibri" charset="0"/>
@@ -9811,7 +9811,7 @@
                           <a:ea typeface="Calibri" pitchFamily="34" charset="-122"/>
                           <a:cs typeface="Calibri" pitchFamily="34" charset="-120"/>
                         </a:rPr>
-                        <a:t>Net passenger-s saved</a:t>
+                        <a:t>Cars arrived (%)</a:t>
                       </a:r>
                       <a:endParaRPr lang="en-US" sz="1150" dirty="0">
                         <a:latin typeface="Calibri" charset="0"/>
@@ -9879,7 +9879,7 @@
                           <a:ea typeface="Calibri" pitchFamily="34" charset="-122"/>
                           <a:cs typeface="Calibri" pitchFamily="34" charset="-120"/>
                         </a:rPr>
-                        <a:t>807</a:t>
+                        <a:t>99.09</a:t>
                       </a:r>
                       <a:endParaRPr lang="en-US" sz="1150" dirty="0">
                         <a:latin typeface="Calibri" charset="0"/>
@@ -9947,7 +9947,7 @@
                           <a:ea typeface="Calibri" pitchFamily="34" charset="-122"/>
                           <a:cs typeface="Calibri" pitchFamily="34" charset="-120"/>
                         </a:rPr>
-                        <a:t>453</a:t>
+                        <a:t>100</a:t>
                       </a:r>
                       <a:endParaRPr lang="en-US" sz="1150" dirty="0">
                         <a:latin typeface="Calibri" charset="0"/>
@@ -10036,7 +10036,7 @@
                 <a:ea typeface="Calibri" pitchFamily="34" charset="-122"/>
                 <a:cs typeface="Calibri" pitchFamily="34" charset="-120"/>
               </a:rPr>
-              <a:t>Ambulance 29.6% faster, 0 s at red, other cars -0.12 s.</a:t>
+              <a:t>Ambulance 42.1% faster and 0 s at red; average car wait 56.3% lower than conventional.</a:t>
             </a:r>
             <a:endParaRPr lang="en-US" sz="1250" dirty="0"/>
           </a:p>
@@ -10053,7 +10053,7 @@
                 <a:ea typeface="Calibri" pitchFamily="34" charset="-122"/>
                 <a:cs typeface="Calibri" pitchFamily="34" charset="-120"/>
               </a:rPr>
-              <a:t>Bus priority: cars wait longer, but more people get through sooner. The junction refuses when the cross street is long.</a:t>
+              <a:t>Honest note: single cars can be slower in our system; the gain is in the average.</a:t>
             </a:r>
             <a:endParaRPr lang="en-US" sz="1250" dirty="0"/>
           </a:p>
@@ -12159,7 +12159,7 @@
                 <a:ea typeface="Arial" pitchFamily="34" charset="-122"/>
                 <a:cs typeface="Arial" pitchFamily="34" charset="-120"/>
               </a:rPr>
-              <a:t>1.44 ms</a:t>
+              <a:t>1.35 ms</a:t>
             </a:r>
             <a:endParaRPr lang="en-US" sz="3600" dirty="0"/>
           </a:p>
@@ -13888,8 +13888,8 @@
         </p:blipFill>
         <p:spPr>
           <a:xfrm>
-            <a:off x="365760" y="1188720"/>
-            <a:ext cx="3840480" cy="3108960"/>
+            <a:off x="274320" y="1188720"/>
+            <a:ext cx="4023360" cy="3474720"/>
           </a:xfrm>
           <a:prstGeom prst="rect">
             <a:avLst/>
@@ -14005,7 +14005,7 @@
                 <a:ea typeface="Calibri" pitchFamily="34" charset="-122"/>
                 <a:cs typeface="Calibri" pitchFamily="34" charset="-120"/>
               </a:rPr>
-              <a:t>Opens the page: 6 cars, 1 accident, who re-routes</a:t>
+              <a:t>Conventional vs ours; click roads to add accidents</a:t>
             </a:r>
             <a:endParaRPr lang="en-US" sz="1200" dirty="0"/>
           </a:p>
@@ -14120,7 +14120,7 @@
                 <a:ea typeface="Calibri" pitchFamily="34" charset="-122"/>
                 <a:cs typeface="Calibri" pitchFamily="34" charset="-120"/>
               </a:rPr>
-              <a:t>Message log (ambulance, bus, incident)</a:t>
+              <a:t>Message log (ambulance, incident)</a:t>
             </a:r>
             <a:endParaRPr lang="en-US" sz="1200" dirty="0"/>
           </a:p>
@@ -14868,7 +14868,7 @@
                 <a:ea typeface="Calibri" pitchFamily="34" charset="-122"/>
                 <a:cs typeface="Calibri" pitchFamily="34" charset="-120"/>
               </a:rPr>
-              <a:t>Green-wave helps corridors only</a:t>
+              <a:t>Green-wave hand-off is optional (no gain on random demand)</a:t>
             </a:r>
             <a:endParaRPr lang="en-US" sz="1500" dirty="0"/>
           </a:p>
@@ -14888,7 +14888,7 @@
                 <a:ea typeface="Calibri" pitchFamily="34" charset="-122"/>
                 <a:cs typeface="Calibri" pitchFamily="34" charset="-120"/>
               </a:rPr>
-              <a:t>Bus priority doubles cross-street car wait</a:t>
+              <a:t>Ambulance assumed to reach every junction by message</a:t>
             </a:r>
             <a:endParaRPr lang="en-US" sz="1500" dirty="0"/>
           </a:p>
@@ -17434,7 +17434,7 @@
                 <a:ea typeface="Arial" pitchFamily="34" charset="-122"/>
                 <a:cs typeface="Arial" pitchFamily="34" charset="-120"/>
               </a:rPr>
-              <a:t>Ambulance + Bus agents</a:t>
+              <a:t>Ambulance agent</a:t>
             </a:r>
             <a:endParaRPr lang="en-US" sz="1300" dirty="0"/>
           </a:p>
@@ -17473,7 +17473,7 @@
                 <a:ea typeface="Calibri" pitchFamily="34" charset="-122"/>
                 <a:cs typeface="Calibri" pitchFamily="34" charset="-120"/>
               </a:rPr>
-              <a:t>Preemption; negotiated priority</a:t>
+              <a:t>Preemption (green corridor)</a:t>
             </a:r>
             <a:endParaRPr lang="en-US" sz="1200" dirty="0"/>
           </a:p>
@@ -18772,7 +18772,7 @@
                           <a:ea typeface="Calibri" pitchFamily="34" charset="-122"/>
                           <a:cs typeface="Calibri" pitchFamily="34" charset="-120"/>
                         </a:rPr>
-                        <a:t>Phase NS / EW / yellow; AGREE, ACCEPT, REJECT</a:t>
+                        <a:t>Phase NS / EW / yellow; AGREE</a:t>
                       </a:r>
                       <a:endParaRPr lang="en-US" sz="1050" dirty="0">
                         <a:latin typeface="Calibri" charset="0"/>
@@ -19594,348 +19594,6 @@
                           <a:ea typeface="Calibri" pitchFamily="34" charset="-122"/>
                           <a:cs typeface="Calibri" pitchFamily="34" charset="-120"/>
                         </a:rPr>
-                        <a:t>Bus</a:t>
-                      </a:r>
-                      <a:endParaRPr lang="en-US" sz="1050" dirty="0">
-                        <a:latin typeface="Calibri" charset="0"/>
-                        <a:ea typeface="Calibri" charset="0"/>
-                        <a:cs typeface="Calibri" charset="0"/>
-                      </a:endParaRPr>
-                    </a:p>
-                  </a:txBody>
-                  <a:tcPr marL="45720" marR="45720" marT="45720" marB="45720" anchor="ctr">
-                    <a:lnL w="6350" cap="flat" cmpd="sng" algn="ctr">
-                      <a:solidFill>
-                        <a:srgbClr val="D9DDE3"/>
-                      </a:solidFill>
-                      <a:prstDash val="solid"/>
-                      <a:round/>
-                      <a:headEnd type="none" w="med" len="med"/>
-                      <a:tailEnd type="none" w="med" len="med"/>
-                    </a:lnL>
-                    <a:lnR w="6350" cap="flat" cmpd="sng" algn="ctr">
-                      <a:solidFill>
-                        <a:srgbClr val="D9DDE3"/>
-                      </a:solidFill>
-                      <a:prstDash val="solid"/>
-                      <a:round/>
-                      <a:headEnd type="none" w="med" len="med"/>
-                      <a:tailEnd type="none" w="med" len="med"/>
-                    </a:lnR>
-                    <a:lnT w="6350" cap="flat" cmpd="sng" algn="ctr">
-                      <a:solidFill>
-                        <a:srgbClr val="D9DDE3"/>
-                      </a:solidFill>
-                      <a:prstDash val="solid"/>
-                      <a:round/>
-                      <a:headEnd type="none" w="med" len="med"/>
-                      <a:tailEnd type="none" w="med" len="med"/>
-                    </a:lnT>
-                    <a:lnB w="6350" cap="flat" cmpd="sng" algn="ctr">
-                      <a:solidFill>
-                        <a:srgbClr val="D9DDE3"/>
-                      </a:solidFill>
-                      <a:prstDash val="solid"/>
-                      <a:round/>
-                      <a:headEnd type="none" w="med" len="med"/>
-                      <a:tailEnd type="none" w="med" len="med"/>
-                    </a:lnB>
-                    <a:solidFill>
-                      <a:srgbClr val="FFFFFF"/>
-                    </a:solidFill>
-                  </a:tcPr>
-                </a:tc>
-                <a:tc>
-                  <a:txBody>
-                    <a:bodyPr/>
-                    <a:lstStyle/>
-                    <a:p>
-                      <a:pPr indent="0" marL="0">
-                        <a:buNone/>
-                      </a:pPr>
-                      <a:r>
-                        <a:rPr lang="en-US" sz="1050" dirty="0">
-                          <a:solidFill>
-                            <a:srgbClr val="1E2530"/>
-                          </a:solidFill>
-                          <a:latin typeface="Calibri" pitchFamily="34" charset="0"/>
-                          <a:ea typeface="Calibri" pitchFamily="34" charset="-122"/>
-                          <a:cs typeface="Calibri" pitchFamily="34" charset="-120"/>
-                        </a:rPr>
-                        <a:t>Min passenger delay, limited harm</a:t>
-                      </a:r>
-                      <a:endParaRPr lang="en-US" sz="1050" dirty="0">
-                        <a:latin typeface="Calibri" charset="0"/>
-                        <a:ea typeface="Calibri" charset="0"/>
-                        <a:cs typeface="Calibri" charset="0"/>
-                      </a:endParaRPr>
-                    </a:p>
-                  </a:txBody>
-                  <a:tcPr marL="45720" marR="45720" marT="45720" marB="45720" anchor="ctr">
-                    <a:lnL w="6350" cap="flat" cmpd="sng" algn="ctr">
-                      <a:solidFill>
-                        <a:srgbClr val="D9DDE3"/>
-                      </a:solidFill>
-                      <a:prstDash val="solid"/>
-                      <a:round/>
-                      <a:headEnd type="none" w="med" len="med"/>
-                      <a:tailEnd type="none" w="med" len="med"/>
-                    </a:lnL>
-                    <a:lnR w="6350" cap="flat" cmpd="sng" algn="ctr">
-                      <a:solidFill>
-                        <a:srgbClr val="D9DDE3"/>
-                      </a:solidFill>
-                      <a:prstDash val="solid"/>
-                      <a:round/>
-                      <a:headEnd type="none" w="med" len="med"/>
-                      <a:tailEnd type="none" w="med" len="med"/>
-                    </a:lnR>
-                    <a:lnT w="6350" cap="flat" cmpd="sng" algn="ctr">
-                      <a:solidFill>
-                        <a:srgbClr val="D9DDE3"/>
-                      </a:solidFill>
-                      <a:prstDash val="solid"/>
-                      <a:round/>
-                      <a:headEnd type="none" w="med" len="med"/>
-                      <a:tailEnd type="none" w="med" len="med"/>
-                    </a:lnT>
-                    <a:lnB w="6350" cap="flat" cmpd="sng" algn="ctr">
-                      <a:solidFill>
-                        <a:srgbClr val="D9DDE3"/>
-                      </a:solidFill>
-                      <a:prstDash val="solid"/>
-                      <a:round/>
-                      <a:headEnd type="none" w="med" len="med"/>
-                      <a:tailEnd type="none" w="med" len="med"/>
-                    </a:lnB>
-                    <a:solidFill>
-                      <a:srgbClr val="FFFFFF"/>
-                    </a:solidFill>
-                  </a:tcPr>
-                </a:tc>
-                <a:tc>
-                  <a:txBody>
-                    <a:bodyPr/>
-                    <a:lstStyle/>
-                    <a:p>
-                      <a:pPr indent="0" marL="0">
-                        <a:buNone/>
-                      </a:pPr>
-                      <a:r>
-                        <a:rPr lang="en-US" sz="1050" dirty="0">
-                          <a:solidFill>
-                            <a:srgbClr val="1E2530"/>
-                          </a:solidFill>
-                          <a:latin typeface="Calibri" pitchFamily="34" charset="0"/>
-                          <a:ea typeface="Calibri" pitchFamily="34" charset="-122"/>
-                          <a:cs typeface="Calibri" pitchFamily="34" charset="-120"/>
-                        </a:rPr>
-                        <a:t>Mixed traffic; junctions may refuse</a:t>
-                      </a:r>
-                      <a:endParaRPr lang="en-US" sz="1050" dirty="0">
-                        <a:latin typeface="Calibri" charset="0"/>
-                        <a:ea typeface="Calibri" charset="0"/>
-                        <a:cs typeface="Calibri" charset="0"/>
-                      </a:endParaRPr>
-                    </a:p>
-                  </a:txBody>
-                  <a:tcPr marL="45720" marR="45720" marT="45720" marB="45720" anchor="ctr">
-                    <a:lnL w="6350" cap="flat" cmpd="sng" algn="ctr">
-                      <a:solidFill>
-                        <a:srgbClr val="D9DDE3"/>
-                      </a:solidFill>
-                      <a:prstDash val="solid"/>
-                      <a:round/>
-                      <a:headEnd type="none" w="med" len="med"/>
-                      <a:tailEnd type="none" w="med" len="med"/>
-                    </a:lnL>
-                    <a:lnR w="6350" cap="flat" cmpd="sng" algn="ctr">
-                      <a:solidFill>
-                        <a:srgbClr val="D9DDE3"/>
-                      </a:solidFill>
-                      <a:prstDash val="solid"/>
-                      <a:round/>
-                      <a:headEnd type="none" w="med" len="med"/>
-                      <a:tailEnd type="none" w="med" len="med"/>
-                    </a:lnR>
-                    <a:lnT w="6350" cap="flat" cmpd="sng" algn="ctr">
-                      <a:solidFill>
-                        <a:srgbClr val="D9DDE3"/>
-                      </a:solidFill>
-                      <a:prstDash val="solid"/>
-                      <a:round/>
-                      <a:headEnd type="none" w="med" len="med"/>
-                      <a:tailEnd type="none" w="med" len="med"/>
-                    </a:lnT>
-                    <a:lnB w="6350" cap="flat" cmpd="sng" algn="ctr">
-                      <a:solidFill>
-                        <a:srgbClr val="D9DDE3"/>
-                      </a:solidFill>
-                      <a:prstDash val="solid"/>
-                      <a:round/>
-                      <a:headEnd type="none" w="med" len="med"/>
-                      <a:tailEnd type="none" w="med" len="med"/>
-                    </a:lnB>
-                    <a:solidFill>
-                      <a:srgbClr val="FFFFFF"/>
-                    </a:solidFill>
-                  </a:tcPr>
-                </a:tc>
-                <a:tc>
-                  <a:txBody>
-                    <a:bodyPr/>
-                    <a:lstStyle/>
-                    <a:p>
-                      <a:pPr indent="0" marL="0">
-                        <a:buNone/>
-                      </a:pPr>
-                      <a:r>
-                        <a:rPr lang="en-US" sz="1050" dirty="0">
-                          <a:solidFill>
-                            <a:srgbClr val="1E2530"/>
-                          </a:solidFill>
-                          <a:latin typeface="Calibri" pitchFamily="34" charset="0"/>
-                          <a:ea typeface="Calibri" pitchFamily="34" charset="-122"/>
-                          <a:cs typeface="Calibri" pitchFamily="34" charset="-120"/>
-                        </a:rPr>
-                        <a:t>PROPOSE, CANCEL</a:t>
-                      </a:r>
-                      <a:endParaRPr lang="en-US" sz="1050" dirty="0">
-                        <a:latin typeface="Calibri" charset="0"/>
-                        <a:ea typeface="Calibri" charset="0"/>
-                        <a:cs typeface="Calibri" charset="0"/>
-                      </a:endParaRPr>
-                    </a:p>
-                  </a:txBody>
-                  <a:tcPr marL="45720" marR="45720" marT="45720" marB="45720" anchor="ctr">
-                    <a:lnL w="6350" cap="flat" cmpd="sng" algn="ctr">
-                      <a:solidFill>
-                        <a:srgbClr val="D9DDE3"/>
-                      </a:solidFill>
-                      <a:prstDash val="solid"/>
-                      <a:round/>
-                      <a:headEnd type="none" w="med" len="med"/>
-                      <a:tailEnd type="none" w="med" len="med"/>
-                    </a:lnL>
-                    <a:lnR w="6350" cap="flat" cmpd="sng" algn="ctr">
-                      <a:solidFill>
-                        <a:srgbClr val="D9DDE3"/>
-                      </a:solidFill>
-                      <a:prstDash val="solid"/>
-                      <a:round/>
-                      <a:headEnd type="none" w="med" len="med"/>
-                      <a:tailEnd type="none" w="med" len="med"/>
-                    </a:lnR>
-                    <a:lnT w="6350" cap="flat" cmpd="sng" algn="ctr">
-                      <a:solidFill>
-                        <a:srgbClr val="D9DDE3"/>
-                      </a:solidFill>
-                      <a:prstDash val="solid"/>
-                      <a:round/>
-                      <a:headEnd type="none" w="med" len="med"/>
-                      <a:tailEnd type="none" w="med" len="med"/>
-                    </a:lnT>
-                    <a:lnB w="6350" cap="flat" cmpd="sng" algn="ctr">
-                      <a:solidFill>
-                        <a:srgbClr val="D9DDE3"/>
-                      </a:solidFill>
-                      <a:prstDash val="solid"/>
-                      <a:round/>
-                      <a:headEnd type="none" w="med" len="med"/>
-                      <a:tailEnd type="none" w="med" len="med"/>
-                    </a:lnB>
-                    <a:solidFill>
-                      <a:srgbClr val="FFFFFF"/>
-                    </a:solidFill>
-                  </a:tcPr>
-                </a:tc>
-                <a:tc>
-                  <a:txBody>
-                    <a:bodyPr/>
-                    <a:lstStyle/>
-                    <a:p>
-                      <a:pPr indent="0" marL="0">
-                        <a:buNone/>
-                      </a:pPr>
-                      <a:r>
-                        <a:rPr lang="en-US" sz="1050" dirty="0">
-                          <a:solidFill>
-                            <a:srgbClr val="1E2530"/>
-                          </a:solidFill>
-                          <a:latin typeface="Calibri" pitchFamily="34" charset="0"/>
-                          <a:ea typeface="Calibri" pitchFamily="34" charset="-122"/>
-                          <a:cs typeface="Calibri" pitchFamily="34" charset="-120"/>
-                        </a:rPr>
-                        <a:t>Next-junction ETA; replies</a:t>
-                      </a:r>
-                      <a:endParaRPr lang="en-US" sz="1050" dirty="0">
-                        <a:latin typeface="Calibri" charset="0"/>
-                        <a:ea typeface="Calibri" charset="0"/>
-                        <a:cs typeface="Calibri" charset="0"/>
-                      </a:endParaRPr>
-                    </a:p>
-                  </a:txBody>
-                  <a:tcPr marL="45720" marR="45720" marT="45720" marB="45720" anchor="ctr">
-                    <a:lnL w="6350" cap="flat" cmpd="sng" algn="ctr">
-                      <a:solidFill>
-                        <a:srgbClr val="D9DDE3"/>
-                      </a:solidFill>
-                      <a:prstDash val="solid"/>
-                      <a:round/>
-                      <a:headEnd type="none" w="med" len="med"/>
-                      <a:tailEnd type="none" w="med" len="med"/>
-                    </a:lnL>
-                    <a:lnR w="6350" cap="flat" cmpd="sng" algn="ctr">
-                      <a:solidFill>
-                        <a:srgbClr val="D9DDE3"/>
-                      </a:solidFill>
-                      <a:prstDash val="solid"/>
-                      <a:round/>
-                      <a:headEnd type="none" w="med" len="med"/>
-                      <a:tailEnd type="none" w="med" len="med"/>
-                    </a:lnR>
-                    <a:lnT w="6350" cap="flat" cmpd="sng" algn="ctr">
-                      <a:solidFill>
-                        <a:srgbClr val="D9DDE3"/>
-                      </a:solidFill>
-                      <a:prstDash val="solid"/>
-                      <a:round/>
-                      <a:headEnd type="none" w="med" len="med"/>
-                      <a:tailEnd type="none" w="med" len="med"/>
-                    </a:lnT>
-                    <a:lnB w="6350" cap="flat" cmpd="sng" algn="ctr">
-                      <a:solidFill>
-                        <a:srgbClr val="D9DDE3"/>
-                      </a:solidFill>
-                      <a:prstDash val="solid"/>
-                      <a:round/>
-                      <a:headEnd type="none" w="med" len="med"/>
-                      <a:tailEnd type="none" w="med" len="med"/>
-                    </a:lnB>
-                    <a:solidFill>
-                      <a:srgbClr val="FFFFFF"/>
-                    </a:solidFill>
-                  </a:tcPr>
-                </a:tc>
-              </a:tr>
-              <a:tr h="0">
-                <a:tc>
-                  <a:txBody>
-                    <a:bodyPr/>
-                    <a:lstStyle/>
-                    <a:p>
-                      <a:pPr indent="0" marL="0">
-                        <a:buNone/>
-                      </a:pPr>
-                      <a:r>
-                        <a:rPr lang="en-US" sz="1050" dirty="0">
-                          <a:solidFill>
-                            <a:srgbClr val="1E2530"/>
-                          </a:solidFill>
-                          <a:latin typeface="Calibri" pitchFamily="34" charset="0"/>
-                          <a:ea typeface="Calibri" pitchFamily="34" charset="-122"/>
-                          <a:cs typeface="Calibri" pitchFamily="34" charset="-120"/>
-                        </a:rPr>
                         <a:t>Coordinator</a:t>
                       </a:r>
                       <a:endParaRPr lang="en-US" sz="1050" dirty="0">
@@ -19983,7 +19641,7 @@
                       <a:tailEnd type="none" w="med" len="med"/>
                     </a:lnB>
                     <a:solidFill>
-                      <a:srgbClr val="F3F5F8"/>
+                      <a:srgbClr val="FFFFFF"/>
                     </a:solidFill>
                   </a:tcPr>
                 </a:tc>
@@ -20051,7 +19709,7 @@
                       <a:tailEnd type="none" w="med" len="med"/>
                     </a:lnB>
                     <a:solidFill>
-                      <a:srgbClr val="F3F5F8"/>
+                      <a:srgbClr val="FFFFFF"/>
                     </a:solidFill>
                   </a:tcPr>
                 </a:tc>
@@ -20119,7 +19777,7 @@
                       <a:tailEnd type="none" w="med" len="med"/>
                     </a:lnB>
                     <a:solidFill>
-                      <a:srgbClr val="F3F5F8"/>
+                      <a:srgbClr val="FFFFFF"/>
                     </a:solidFill>
                   </a:tcPr>
                 </a:tc>
@@ -20187,7 +19845,7 @@
                       <a:tailEnd type="none" w="med" len="med"/>
                     </a:lnB>
                     <a:solidFill>
-                      <a:srgbClr val="F3F5F8"/>
+                      <a:srgbClr val="FFFFFF"/>
                     </a:solidFill>
                   </a:tcPr>
                 </a:tc>
@@ -20255,7 +19913,7 @@
                       <a:tailEnd type="none" w="med" len="med"/>
                     </a:lnB>
                     <a:solidFill>
-                      <a:srgbClr val="F3F5F8"/>
+                      <a:srgbClr val="FFFFFF"/>
                     </a:solidFill>
                   </a:tcPr>
                 </a:tc>
@@ -21656,144 +21314,6 @@
                           <a:ea typeface="Calibri" pitchFamily="34" charset="-122"/>
                           <a:cs typeface="Calibri" pitchFamily="34" charset="-120"/>
                         </a:rPr>
-                        <a:t>Bus</a:t>
-                      </a:r>
-                      <a:endParaRPr lang="en-US" sz="1150" dirty="0">
-                        <a:latin typeface="Calibri" charset="0"/>
-                        <a:ea typeface="Calibri" charset="0"/>
-                        <a:cs typeface="Calibri" charset="0"/>
-                      </a:endParaRPr>
-                    </a:p>
-                  </a:txBody>
-                  <a:tcPr marL="45720" marR="45720" marT="45720" marB="45720" anchor="ctr">
-                    <a:lnL w="6350" cap="flat" cmpd="sng" algn="ctr">
-                      <a:solidFill>
-                        <a:srgbClr val="D9DDE3"/>
-                      </a:solidFill>
-                      <a:prstDash val="solid"/>
-                      <a:round/>
-                      <a:headEnd type="none" w="med" len="med"/>
-                      <a:tailEnd type="none" w="med" len="med"/>
-                    </a:lnL>
-                    <a:lnR w="6350" cap="flat" cmpd="sng" algn="ctr">
-                      <a:solidFill>
-                        <a:srgbClr val="D9DDE3"/>
-                      </a:solidFill>
-                      <a:prstDash val="solid"/>
-                      <a:round/>
-                      <a:headEnd type="none" w="med" len="med"/>
-                      <a:tailEnd type="none" w="med" len="med"/>
-                    </a:lnR>
-                    <a:lnT w="6350" cap="flat" cmpd="sng" algn="ctr">
-                      <a:solidFill>
-                        <a:srgbClr val="D9DDE3"/>
-                      </a:solidFill>
-                      <a:prstDash val="solid"/>
-                      <a:round/>
-                      <a:headEnd type="none" w="med" len="med"/>
-                      <a:tailEnd type="none" w="med" len="med"/>
-                    </a:lnT>
-                    <a:lnB w="6350" cap="flat" cmpd="sng" algn="ctr">
-                      <a:solidFill>
-                        <a:srgbClr val="D9DDE3"/>
-                      </a:solidFill>
-                      <a:prstDash val="solid"/>
-                      <a:round/>
-                      <a:headEnd type="none" w="med" len="med"/>
-                      <a:tailEnd type="none" w="med" len="med"/>
-                    </a:lnB>
-                    <a:solidFill>
-                      <a:srgbClr val="FFFFFF"/>
-                    </a:solidFill>
-                  </a:tcPr>
-                </a:tc>
-                <a:tc>
-                  <a:txBody>
-                    <a:bodyPr/>
-                    <a:lstStyle/>
-                    <a:p>
-                      <a:pPr indent="0" marL="0">
-                        <a:buNone/>
-                      </a:pPr>
-                      <a:r>
-                        <a:rPr lang="en-US" sz="1150" dirty="0">
-                          <a:solidFill>
-                            <a:srgbClr val="1E2530"/>
-                          </a:solidFill>
-                          <a:latin typeface="Calibri" pitchFamily="34" charset="0"/>
-                          <a:ea typeface="Calibri" pitchFamily="34" charset="-122"/>
-                          <a:cs typeface="Calibri" pitchFamily="34" charset="-120"/>
-                        </a:rPr>
-                        <a:t>Utility-based negotiator</a:t>
-                      </a:r>
-                      <a:endParaRPr lang="en-US" sz="1150" dirty="0">
-                        <a:latin typeface="Calibri" charset="0"/>
-                        <a:ea typeface="Calibri" charset="0"/>
-                        <a:cs typeface="Calibri" charset="0"/>
-                      </a:endParaRPr>
-                    </a:p>
-                  </a:txBody>
-                  <a:tcPr marL="45720" marR="45720" marT="45720" marB="45720" anchor="ctr">
-                    <a:lnL w="6350" cap="flat" cmpd="sng" algn="ctr">
-                      <a:solidFill>
-                        <a:srgbClr val="D9DDE3"/>
-                      </a:solidFill>
-                      <a:prstDash val="solid"/>
-                      <a:round/>
-                      <a:headEnd type="none" w="med" len="med"/>
-                      <a:tailEnd type="none" w="med" len="med"/>
-                    </a:lnL>
-                    <a:lnR w="6350" cap="flat" cmpd="sng" algn="ctr">
-                      <a:solidFill>
-                        <a:srgbClr val="D9DDE3"/>
-                      </a:solidFill>
-                      <a:prstDash val="solid"/>
-                      <a:round/>
-                      <a:headEnd type="none" w="med" len="med"/>
-                      <a:tailEnd type="none" w="med" len="med"/>
-                    </a:lnR>
-                    <a:lnT w="6350" cap="flat" cmpd="sng" algn="ctr">
-                      <a:solidFill>
-                        <a:srgbClr val="D9DDE3"/>
-                      </a:solidFill>
-                      <a:prstDash val="solid"/>
-                      <a:round/>
-                      <a:headEnd type="none" w="med" len="med"/>
-                      <a:tailEnd type="none" w="med" len="med"/>
-                    </a:lnT>
-                    <a:lnB w="6350" cap="flat" cmpd="sng" algn="ctr">
-                      <a:solidFill>
-                        <a:srgbClr val="D9DDE3"/>
-                      </a:solidFill>
-                      <a:prstDash val="solid"/>
-                      <a:round/>
-                      <a:headEnd type="none" w="med" len="med"/>
-                      <a:tailEnd type="none" w="med" len="med"/>
-                    </a:lnB>
-                    <a:solidFill>
-                      <a:srgbClr val="FFFFFF"/>
-                    </a:solidFill>
-                  </a:tcPr>
-                </a:tc>
-              </a:tr>
-              <a:tr h="402336">
-                <a:tc>
-                  <a:txBody>
-                    <a:bodyPr/>
-                    <a:lstStyle/>
-                    <a:p>
-                      <a:pPr indent="0" marL="0">
-                        <a:buNone/>
-                      </a:pPr>
-                      <a:r>
-                        <a:rPr lang="en-US" sz="1150" dirty="0">
-                          <a:solidFill>
-                            <a:srgbClr val="1E2530"/>
-                          </a:solidFill>
-                          <a:latin typeface="Calibri" pitchFamily="34" charset="0"/>
-                          <a:ea typeface="Calibri" pitchFamily="34" charset="-122"/>
-                          <a:cs typeface="Calibri" pitchFamily="34" charset="-120"/>
-                        </a:rPr>
                         <a:t>Coordinator</a:t>
                       </a:r>
                       <a:endParaRPr lang="en-US" sz="1150" dirty="0">
@@ -21841,7 +21361,7 @@
                       <a:tailEnd type="none" w="med" len="med"/>
                     </a:lnB>
                     <a:solidFill>
-                      <a:srgbClr val="F3F5F8"/>
+                      <a:srgbClr val="FFFFFF"/>
                     </a:solidFill>
                   </a:tcPr>
                 </a:tc>
@@ -21909,7 +21429,7 @@
                       <a:tailEnd type="none" w="med" len="med"/>
                     </a:lnB>
                     <a:solidFill>
-                      <a:srgbClr val="F3F5F8"/>
+                      <a:srgbClr val="FFFFFF"/>
                     </a:solidFill>
                   </a:tcPr>
                 </a:tc>

</xml_diff>

<commit_message>
Dense traffic, Send Car/Ambulance, + signals
</commit_message>
<xml_diff>
--- a/deliverables/STMS_Presentation.pptx
+++ b/deliverables/STMS_Presentation.pptx
@@ -9261,7 +9261,7 @@
                           <a:ea typeface="Calibri" pitchFamily="34" charset="-122"/>
                           <a:cs typeface="Calibri" pitchFamily="34" charset="-120"/>
                         </a:rPr>
-                        <a:t>126.0</a:t>
+                        <a:t>91.0</a:t>
                       </a:r>
                       <a:endParaRPr lang="en-US" sz="1150" dirty="0">
                         <a:latin typeface="Calibri" charset="0"/>
@@ -9467,7 +9467,7 @@
                           <a:ea typeface="Calibri" pitchFamily="34" charset="-122"/>
                           <a:cs typeface="Calibri" pitchFamily="34" charset="-120"/>
                         </a:rPr>
-                        <a:t>47.0</a:t>
+                        <a:t>16.0</a:t>
                       </a:r>
                       <a:endParaRPr lang="en-US" sz="1150" dirty="0">
                         <a:latin typeface="Calibri" charset="0"/>
@@ -9673,7 +9673,7 @@
                           <a:ea typeface="Calibri" pitchFamily="34" charset="-122"/>
                           <a:cs typeface="Calibri" pitchFamily="34" charset="-120"/>
                         </a:rPr>
-                        <a:t>21.25</a:t>
+                        <a:t>24.79</a:t>
                       </a:r>
                       <a:endParaRPr lang="en-US" sz="1150" dirty="0">
                         <a:latin typeface="Calibri" charset="0"/>
@@ -9741,7 +9741,7 @@
                           <a:ea typeface="Calibri" pitchFamily="34" charset="-122"/>
                           <a:cs typeface="Calibri" pitchFamily="34" charset="-120"/>
                         </a:rPr>
-                        <a:t>9.28</a:t>
+                        <a:t>17.62</a:t>
                       </a:r>
                       <a:endParaRPr lang="en-US" sz="1150" dirty="0">
                         <a:latin typeface="Calibri" charset="0"/>
@@ -9879,7 +9879,7 @@
                           <a:ea typeface="Calibri" pitchFamily="34" charset="-122"/>
                           <a:cs typeface="Calibri" pitchFamily="34" charset="-120"/>
                         </a:rPr>
-                        <a:t>99.09</a:t>
+                        <a:t>87.29</a:t>
                       </a:r>
                       <a:endParaRPr lang="en-US" sz="1150" dirty="0">
                         <a:latin typeface="Calibri" charset="0"/>
@@ -9947,7 +9947,7 @@
                           <a:ea typeface="Calibri" pitchFamily="34" charset="-122"/>
                           <a:cs typeface="Calibri" pitchFamily="34" charset="-120"/>
                         </a:rPr>
-                        <a:t>100</a:t>
+                        <a:t>93.47</a:t>
                       </a:r>
                       <a:endParaRPr lang="en-US" sz="1150" dirty="0">
                         <a:latin typeface="Calibri" charset="0"/>
@@ -10036,7 +10036,7 @@
                 <a:ea typeface="Calibri" pitchFamily="34" charset="-122"/>
                 <a:cs typeface="Calibri" pitchFamily="34" charset="-120"/>
               </a:rPr>
-              <a:t>Ambulance 42.1% faster and 0 s at red; average car wait 56.3% lower than conventional.</a:t>
+              <a:t>Ambulance 19.8% faster and 0 s at red; average car wait 28.9% lower than conventional.</a:t>
             </a:r>
             <a:endParaRPr lang="en-US" sz="1250" dirty="0"/>
           </a:p>
@@ -12159,7 +12159,7 @@
                 <a:ea typeface="Arial" pitchFamily="34" charset="-122"/>
                 <a:cs typeface="Arial" pitchFamily="34" charset="-120"/>
               </a:rPr>
-              <a:t>1.59 ms</a:t>
+              <a:t>2.39 ms</a:t>
             </a:r>
             <a:endParaRPr lang="en-US" sz="3600" dirty="0"/>
           </a:p>
@@ -12530,7 +12530,7 @@
                 <a:ea typeface="Arial" pitchFamily="34" charset="-122"/>
                 <a:cs typeface="Arial" pitchFamily="34" charset="-120"/>
               </a:rPr>
-              <a:t>43/43</a:t>
+              <a:t>45/45</a:t>
             </a:r>
             <a:endParaRPr lang="en-US" sz="3600" dirty="0"/>
           </a:p>
@@ -16348,7 +16348,7 @@
                 <a:ea typeface="Arial" pitchFamily="34" charset="-122"/>
                 <a:cs typeface="Arial" pitchFamily="34" charset="-120"/>
               </a:rPr>
-              <a:t>43/43</a:t>
+              <a:t>45/45</a:t>
             </a:r>
             <a:endParaRPr lang="en-US" sz="3200" dirty="0"/>
           </a:p>

</xml_diff>